<commit_message>
exercises.html code.zip generator.pdf generator.pptx
</commit_message>
<xml_diff>
--- a/ipsa/slides/generator.pptx
+++ b/ipsa/slides/generator.pptx
@@ -150,7 +150,7 @@
   <pc:docChgLst>
     <pc:chgData name="Gerth Stølting Brodal" userId="04ef4784-6591-4f86-a140-f5c3b108582a" providerId="ADAL" clId="{73BAC7D6-516A-44B5-B4B0-C7B08CA8B392}"/>
     <pc:docChg chg="undo custSel modSld">
-      <pc:chgData name="Gerth Stølting Brodal" userId="04ef4784-6591-4f86-a140-f5c3b108582a" providerId="ADAL" clId="{73BAC7D6-516A-44B5-B4B0-C7B08CA8B392}" dt="2026-04-14T22:53:22.550" v="571" actId="20577"/>
+      <pc:chgData name="Gerth Stølting Brodal" userId="04ef4784-6591-4f86-a140-f5c3b108582a" providerId="ADAL" clId="{73BAC7D6-516A-44B5-B4B0-C7B08CA8B392}" dt="2026-04-19T22:02:43.674" v="578" actId="790"/>
       <pc:docMkLst>
         <pc:docMk/>
       </pc:docMkLst>
@@ -708,8 +708,8 @@
           </ac:spMkLst>
         </pc:spChg>
       </pc:sldChg>
-      <pc:sldChg chg="modSp mod">
-        <pc:chgData name="Gerth Stølting Brodal" userId="04ef4784-6591-4f86-a140-f5c3b108582a" providerId="ADAL" clId="{73BAC7D6-516A-44B5-B4B0-C7B08CA8B392}" dt="2026-04-14T21:42:39.634" v="0" actId="790"/>
+      <pc:sldChg chg="modSp mod modNotesTx">
+        <pc:chgData name="Gerth Stølting Brodal" userId="04ef4784-6591-4f86-a140-f5c3b108582a" providerId="ADAL" clId="{73BAC7D6-516A-44B5-B4B0-C7B08CA8B392}" dt="2026-04-19T22:02:43.674" v="578" actId="790"/>
         <pc:sldMkLst>
           <pc:docMk/>
           <pc:sldMk cId="3310034871" sldId="786"/>
@@ -826,7 +826,7 @@
         </pc:graphicFrameChg>
       </pc:sldChg>
       <pc:sldChg chg="modSp mod modNotesTx">
-        <pc:chgData name="Gerth Stølting Brodal" userId="04ef4784-6591-4f86-a140-f5c3b108582a" providerId="ADAL" clId="{73BAC7D6-516A-44B5-B4B0-C7B08CA8B392}" dt="2026-04-14T22:38:58.554" v="562" actId="20577"/>
+        <pc:chgData name="Gerth Stølting Brodal" userId="04ef4784-6591-4f86-a140-f5c3b108582a" providerId="ADAL" clId="{73BAC7D6-516A-44B5-B4B0-C7B08CA8B392}" dt="2026-04-19T22:02:21.091" v="577" actId="790"/>
         <pc:sldMkLst>
           <pc:docMk/>
           <pc:sldMk cId="3474449255" sldId="790"/>
@@ -1277,7 +1277,7 @@
         </pc:graphicFrameChg>
       </pc:sldChg>
       <pc:sldChg chg="modSp mod modNotesTx">
-        <pc:chgData name="Gerth Stølting Brodal" userId="04ef4784-6591-4f86-a140-f5c3b108582a" providerId="ADAL" clId="{73BAC7D6-516A-44B5-B4B0-C7B08CA8B392}" dt="2026-04-14T22:53:22.550" v="571" actId="20577"/>
+        <pc:chgData name="Gerth Stølting Brodal" userId="04ef4784-6591-4f86-a140-f5c3b108582a" providerId="ADAL" clId="{73BAC7D6-516A-44B5-B4B0-C7B08CA8B392}" dt="2026-04-19T22:01:52.133" v="576" actId="790"/>
         <pc:sldMkLst>
           <pc:docMk/>
           <pc:sldMk cId="702637341" sldId="804"/>
@@ -1418,7 +1418,7 @@
           <a:p>
             <a:fld id="{FB1A172F-81D4-4DC4-9113-1DBD56EC3646}" type="datetimeFigureOut">
               <a:rPr lang="en-US" smtClean="0"/>
-              <a:t>4/14/2026</a:t>
+              <a:t>4/19/2026</a:t>
             </a:fld>
             <a:endParaRPr lang="en-US"/>
           </a:p>
@@ -2121,45 +2121,28 @@
           <a:lstStyle/>
           <a:p>
             <a:r>
-              <a:rPr lang="da-DK" dirty="0"/>
+              <a:rPr lang="en-US" noProof="0" dirty="0"/>
               <a:t>Python 3.12 bug: </a:t>
             </a:r>
             <a:r>
-              <a:rPr lang="da-DK" dirty="0" err="1"/>
+              <a:rPr lang="en-US" noProof="0" dirty="0" err="1"/>
               <a:t>r.close</a:t>
             </a:r>
             <a:r>
-              <a:rPr lang="da-DK" dirty="0"/>
-              <a:t> </a:t>
-            </a:r>
-            <a:r>
-              <a:rPr lang="da-DK" dirty="0" err="1"/>
-              <a:t>does</a:t>
-            </a:r>
-            <a:r>
-              <a:rPr lang="da-DK" dirty="0"/>
-              <a:t> not release </a:t>
-            </a:r>
-            <a:r>
-              <a:rPr lang="da-DK" dirty="0" err="1"/>
-              <a:t>resources</a:t>
-            </a:r>
-            <a:endParaRPr lang="da-DK" dirty="0"/>
+              <a:rPr lang="en-US" noProof="0" dirty="0"/>
+              <a:t> does not release resources</a:t>
+            </a:r>
           </a:p>
           <a:p>
             <a:r>
-              <a:rPr lang="da-DK" dirty="0"/>
+              <a:rPr lang="en-US" noProof="0" dirty="0"/>
               <a:t>https://github.com/python/cpython/issues/118272</a:t>
             </a:r>
           </a:p>
           <a:p>
             <a:r>
-              <a:rPr lang="da-DK" dirty="0" err="1"/>
-              <a:t>Fixed</a:t>
-            </a:r>
-            <a:r>
-              <a:rPr lang="da-DK" dirty="0"/>
-              <a:t> in 3.14</a:t>
+              <a:rPr lang="en-US" noProof="0" dirty="0"/>
+              <a:t>Fixed in 3.13</a:t>
             </a:r>
           </a:p>
         </p:txBody>
@@ -2901,193 +2884,73 @@
           <a:lstStyle/>
           <a:p>
             <a:r>
-              <a:rPr lang="en-US" dirty="0"/>
+              <a:rPr lang="en-US" noProof="0" dirty="0"/>
               <a:t>zip</a:t>
             </a:r>
             <a:r>
-              <a:rPr lang="en-US" baseline="0" dirty="0"/>
+              <a:rPr lang="en-US" baseline="0" noProof="0" dirty="0"/>
               <a:t> takes a sequence of </a:t>
             </a:r>
             <a:r>
-              <a:rPr lang="en-US" baseline="0" dirty="0" err="1"/>
+              <a:rPr lang="en-US" baseline="0" noProof="0" dirty="0" err="1"/>
               <a:t>iterables</a:t>
             </a:r>
             <a:r>
-              <a:rPr lang="en-US" baseline="0" dirty="0"/>
+              <a:rPr lang="en-US" baseline="0" noProof="0" dirty="0"/>
               <a:t> and creates an </a:t>
             </a:r>
             <a:r>
-              <a:rPr lang="en-US" baseline="0" dirty="0" err="1"/>
+              <a:rPr lang="en-US" baseline="0" noProof="0" dirty="0" err="1"/>
               <a:t>iterable</a:t>
             </a:r>
-            <a:endParaRPr lang="en-US" baseline="0" dirty="0"/>
+            <a:endParaRPr lang="en-US" baseline="0" noProof="0" dirty="0"/>
           </a:p>
           <a:p>
             <a:r>
-              <a:rPr lang="en-US" baseline="0" dirty="0"/>
+              <a:rPr lang="en-US" baseline="0" noProof="0" dirty="0"/>
               <a:t>for zip the iterator equals the </a:t>
             </a:r>
             <a:r>
-              <a:rPr lang="en-US" baseline="0" dirty="0" err="1"/>
+              <a:rPr lang="en-US" baseline="0" noProof="0" dirty="0" err="1"/>
               <a:t>iterable</a:t>
             </a:r>
             <a:r>
-              <a:rPr lang="en-US" baseline="0" dirty="0"/>
+              <a:rPr lang="en-US" baseline="0" noProof="0" dirty="0"/>
               <a:t>, i.e. </a:t>
             </a:r>
             <a:r>
-              <a:rPr lang="en-US" baseline="0" dirty="0">
+              <a:rPr lang="en-US" baseline="0" noProof="0" dirty="0">
                 <a:latin typeface="Courier"/>
               </a:rPr>
-              <a:t>z is </a:t>
-            </a:r>
-            <a:r>
-              <a:rPr lang="en-US" baseline="0" dirty="0" err="1">
-                <a:latin typeface="Courier"/>
-              </a:rPr>
-              <a:t>iter</a:t>
-            </a:r>
-            <a:r>
-              <a:rPr lang="en-US" baseline="0" dirty="0">
-                <a:latin typeface="Courier"/>
-              </a:rPr>
-              <a:t>(zip) == True</a:t>
+              <a:t>z is iter(zip) == True</a:t>
             </a:r>
           </a:p>
           <a:p>
-            <a:endParaRPr lang="en-US" baseline="0" dirty="0">
+            <a:endParaRPr lang="en-US" baseline="0" noProof="0" dirty="0">
               <a:latin typeface="Courier"/>
             </a:endParaRPr>
           </a:p>
           <a:p>
             <a:r>
-              <a:rPr lang="en-US" baseline="0" dirty="0">
+              <a:rPr lang="en-US" baseline="0" noProof="0" dirty="0">
                 <a:latin typeface="Courier"/>
               </a:rPr>
               <a:t>if “it” is replaced by “r” in for loops, then the counting will always start from 42</a:t>
             </a:r>
           </a:p>
           <a:p>
-            <a:endParaRPr lang="da-DK" baseline="0" dirty="0">
+            <a:endParaRPr lang="en-US" baseline="0" noProof="0" dirty="0">
               <a:latin typeface="Courier"/>
             </a:endParaRPr>
           </a:p>
           <a:p>
             <a:r>
-              <a:rPr lang="da-DK" baseline="0" dirty="0">
+              <a:rPr lang="en-US" baseline="0" noProof="0" dirty="0">
                 <a:latin typeface="Courier"/>
               </a:rPr>
-              <a:t>if ”range(5)” and ”it” </a:t>
-            </a:r>
-            <a:r>
-              <a:rPr lang="da-DK" baseline="0" dirty="0" err="1">
-                <a:latin typeface="Courier"/>
-              </a:rPr>
-              <a:t>are</a:t>
-            </a:r>
-            <a:r>
-              <a:rPr lang="da-DK" baseline="0" dirty="0">
-                <a:latin typeface="Courier"/>
-              </a:rPr>
-              <a:t> </a:t>
-            </a:r>
-            <a:r>
-              <a:rPr lang="da-DK" baseline="0" dirty="0" err="1">
-                <a:latin typeface="Courier"/>
-              </a:rPr>
-              <a:t>swapped</a:t>
-            </a:r>
-            <a:r>
-              <a:rPr lang="da-DK" baseline="0" dirty="0">
-                <a:latin typeface="Courier"/>
-              </a:rPr>
-              <a:t> in zip, </a:t>
-            </a:r>
-            <a:r>
-              <a:rPr lang="da-DK" baseline="0" dirty="0" err="1">
-                <a:latin typeface="Courier"/>
-              </a:rPr>
-              <a:t>then</a:t>
-            </a:r>
-            <a:r>
-              <a:rPr lang="da-DK" baseline="0" dirty="0">
-                <a:latin typeface="Courier"/>
-              </a:rPr>
-              <a:t> zip </a:t>
-            </a:r>
-            <a:r>
-              <a:rPr lang="da-DK" baseline="0" dirty="0" err="1">
-                <a:latin typeface="Courier"/>
-              </a:rPr>
-              <a:t>will</a:t>
-            </a:r>
-            <a:r>
-              <a:rPr lang="da-DK" baseline="0" dirty="0">
-                <a:latin typeface="Courier"/>
-              </a:rPr>
-              <a:t> </a:t>
-            </a:r>
-            <a:r>
-              <a:rPr lang="da-DK" baseline="0" dirty="0" err="1">
-                <a:latin typeface="Courier"/>
-              </a:rPr>
-              <a:t>eat</a:t>
-            </a:r>
-            <a:r>
-              <a:rPr lang="da-DK" baseline="0" dirty="0">
-                <a:latin typeface="Courier"/>
-              </a:rPr>
-              <a:t> </a:t>
-            </a:r>
-            <a:r>
-              <a:rPr lang="da-DK" baseline="0" dirty="0" err="1">
-                <a:latin typeface="Courier"/>
-              </a:rPr>
-              <a:t>one</a:t>
-            </a:r>
-            <a:r>
-              <a:rPr lang="da-DK" baseline="0" dirty="0">
-                <a:latin typeface="Courier"/>
-              </a:rPr>
-              <a:t> element of ”it” and the </a:t>
-            </a:r>
-            <a:r>
-              <a:rPr lang="da-DK" baseline="0" dirty="0" err="1">
-                <a:latin typeface="Courier"/>
-              </a:rPr>
-              <a:t>second</a:t>
-            </a:r>
-            <a:r>
-              <a:rPr lang="da-DK" baseline="0" dirty="0">
-                <a:latin typeface="Courier"/>
-              </a:rPr>
-              <a:t> </a:t>
-            </a:r>
-            <a:r>
-              <a:rPr lang="da-DK" baseline="0" dirty="0" err="1">
-                <a:latin typeface="Courier"/>
-              </a:rPr>
-              <a:t>counting</a:t>
-            </a:r>
-            <a:r>
-              <a:rPr lang="da-DK" baseline="0" dirty="0">
-                <a:latin typeface="Courier"/>
-              </a:rPr>
-              <a:t> </a:t>
-            </a:r>
-            <a:r>
-              <a:rPr lang="da-DK" baseline="0" dirty="0" err="1">
-                <a:latin typeface="Courier"/>
-              </a:rPr>
-              <a:t>will</a:t>
-            </a:r>
-            <a:r>
-              <a:rPr lang="da-DK" baseline="0" dirty="0">
-                <a:latin typeface="Courier"/>
-              </a:rPr>
-              <a:t> start at 24..12 !!!</a:t>
-            </a:r>
-            <a:endParaRPr lang="en-US" dirty="0">
+              <a:t>if ”range(5)” and ”it” are swapped in zip, then zip will eat one element of ”it” and the second counting will start at 24..12 !!!</a:t>
+            </a:r>
+            <a:endParaRPr lang="en-US" noProof="0" dirty="0">
               <a:latin typeface="Courier"/>
             </a:endParaRPr>
           </a:p>
@@ -3541,177 +3404,38 @@
           <a:lstStyle/>
           <a:p>
             <a:r>
-              <a:rPr lang="en-US" dirty="0"/>
+              <a:rPr lang="en-US" noProof="0" dirty="0"/>
               <a:t>o = (x ** 2 for x in range(5))</a:t>
             </a:r>
           </a:p>
           <a:p>
             <a:r>
-              <a:rPr lang="es-ES" dirty="0"/>
-              <a:t>for y in o: </a:t>
-            </a:r>
-            <a:r>
-              <a:rPr lang="es-ES" dirty="0" err="1"/>
-              <a:t>print</a:t>
-            </a:r>
-            <a:r>
-              <a:rPr lang="es-ES" dirty="0"/>
-              <a:t>(y)  # </a:t>
-            </a:r>
-            <a:r>
-              <a:rPr lang="es-ES" dirty="0" err="1"/>
-              <a:t>print</a:t>
-            </a:r>
-            <a:r>
-              <a:rPr lang="es-ES" dirty="0"/>
-              <a:t> </a:t>
-            </a:r>
-            <a:r>
-              <a:rPr lang="es-ES" dirty="0" err="1"/>
-              <a:t>all</a:t>
-            </a:r>
-            <a:r>
-              <a:rPr lang="es-ES" dirty="0"/>
-              <a:t> </a:t>
-            </a:r>
-            <a:r>
-              <a:rPr lang="es-ES" dirty="0" err="1"/>
-              <a:t>squares</a:t>
-            </a:r>
-            <a:endParaRPr lang="es-ES" dirty="0"/>
+              <a:rPr lang="en-US" noProof="0" dirty="0"/>
+              <a:t>for y in o: print(y)  # print all squares</a:t>
+            </a:r>
           </a:p>
           <a:p>
             <a:r>
-              <a:rPr lang="es-ES" dirty="0"/>
-              <a:t>for y in o: </a:t>
-            </a:r>
-            <a:r>
-              <a:rPr lang="es-ES" dirty="0" err="1"/>
-              <a:t>print</a:t>
-            </a:r>
-            <a:r>
-              <a:rPr lang="es-ES" dirty="0"/>
-              <a:t>(y)  # </a:t>
-            </a:r>
-            <a:r>
-              <a:rPr lang="es-ES" dirty="0" err="1"/>
-              <a:t>prints</a:t>
-            </a:r>
-            <a:r>
-              <a:rPr lang="es-ES" dirty="0"/>
-              <a:t> </a:t>
-            </a:r>
-            <a:r>
-              <a:rPr lang="es-ES" dirty="0" err="1"/>
-              <a:t>nothing</a:t>
-            </a:r>
-            <a:r>
-              <a:rPr lang="es-ES" dirty="0"/>
-              <a:t>, </a:t>
-            </a:r>
-            <a:r>
-              <a:rPr lang="es-ES" dirty="0" err="1"/>
-              <a:t>since</a:t>
-            </a:r>
-            <a:r>
-              <a:rPr lang="es-ES" dirty="0"/>
-              <a:t> </a:t>
-            </a:r>
-            <a:r>
-              <a:rPr lang="es-ES" dirty="0" err="1"/>
-              <a:t>generator</a:t>
-            </a:r>
-            <a:r>
-              <a:rPr lang="es-ES" dirty="0"/>
-              <a:t> </a:t>
-            </a:r>
-            <a:r>
-              <a:rPr lang="es-ES" dirty="0" err="1"/>
-              <a:t>expression</a:t>
-            </a:r>
-            <a:r>
-              <a:rPr lang="es-ES" dirty="0"/>
-              <a:t> </a:t>
-            </a:r>
-            <a:r>
-              <a:rPr lang="es-ES" dirty="0" err="1"/>
-              <a:t>is</a:t>
-            </a:r>
-            <a:r>
-              <a:rPr lang="es-ES" dirty="0"/>
-              <a:t> </a:t>
-            </a:r>
-            <a:r>
-              <a:rPr lang="es-ES" dirty="0" err="1"/>
-              <a:t>exhausted</a:t>
-            </a:r>
-            <a:endParaRPr lang="es-ES" dirty="0"/>
+              <a:rPr lang="en-US" noProof="0" dirty="0"/>
+              <a:t>for y in o: print(y)  # prints nothing, since generator expression is exhausted</a:t>
+            </a:r>
           </a:p>
           <a:p>
             <a:r>
-              <a:rPr lang="es-ES" dirty="0" err="1"/>
-              <a:t>iter</a:t>
-            </a:r>
-            <a:r>
-              <a:rPr lang="es-ES" dirty="0"/>
-              <a:t>(o) </a:t>
-            </a:r>
-            <a:r>
-              <a:rPr lang="es-ES" dirty="0" err="1"/>
-              <a:t>is</a:t>
-            </a:r>
-            <a:r>
-              <a:rPr lang="es-ES" dirty="0"/>
-              <a:t> o   # </a:t>
-            </a:r>
-            <a:r>
-              <a:rPr lang="es-ES" dirty="0" err="1"/>
-              <a:t>the</a:t>
-            </a:r>
-            <a:r>
-              <a:rPr lang="es-ES" dirty="0"/>
-              <a:t> iterable </a:t>
-            </a:r>
-            <a:r>
-              <a:rPr lang="es-ES" dirty="0" err="1"/>
-              <a:t>is</a:t>
-            </a:r>
-            <a:r>
-              <a:rPr lang="es-ES" dirty="0"/>
-              <a:t> </a:t>
-            </a:r>
-            <a:r>
-              <a:rPr lang="es-ES" dirty="0" err="1"/>
-              <a:t>also</a:t>
-            </a:r>
-            <a:r>
-              <a:rPr lang="es-ES" dirty="0"/>
-              <a:t> </a:t>
-            </a:r>
-            <a:r>
-              <a:rPr lang="es-ES" dirty="0" err="1"/>
-              <a:t>the</a:t>
-            </a:r>
-            <a:r>
-              <a:rPr lang="es-ES" dirty="0"/>
-              <a:t> </a:t>
-            </a:r>
-            <a:r>
-              <a:rPr lang="es-ES" dirty="0" err="1"/>
-              <a:t>iterator</a:t>
-            </a:r>
-            <a:r>
-              <a:rPr lang="es-ES" dirty="0"/>
-              <a:t> for </a:t>
-            </a:r>
-            <a:r>
-              <a:rPr lang="es-ES" dirty="0" err="1"/>
-              <a:t>itself</a:t>
-            </a:r>
-            <a:endParaRPr lang="es-ES" dirty="0"/>
+              <a:rPr lang="en-US" noProof="0" dirty="0"/>
+              <a:t>iter(o) is o   # the </a:t>
+            </a:r>
+            <a:r>
+              <a:rPr lang="en-US" noProof="0" dirty="0" err="1"/>
+              <a:t>iterable</a:t>
+            </a:r>
+            <a:r>
+              <a:rPr lang="en-US" noProof="0" dirty="0"/>
+              <a:t> is also the iterator for itself</a:t>
+            </a:r>
           </a:p>
           <a:p>
-            <a:endParaRPr lang="en-US" dirty="0"/>
+            <a:endParaRPr lang="en-US" noProof="0" dirty="0"/>
           </a:p>
         </p:txBody>
       </p:sp>
@@ -3984,7 +3708,7 @@
           <a:p>
             <a:fld id="{0560A9CD-0304-4E0B-9E82-E7E0115DE05B}" type="datetimeFigureOut">
               <a:rPr lang="en-US" smtClean="0"/>
-              <a:t>4/14/2026</a:t>
+              <a:t>4/19/2026</a:t>
             </a:fld>
             <a:endParaRPr lang="en-US"/>
           </a:p>
@@ -4152,7 +3876,7 @@
           <a:p>
             <a:fld id="{0560A9CD-0304-4E0B-9E82-E7E0115DE05B}" type="datetimeFigureOut">
               <a:rPr lang="en-US" smtClean="0"/>
-              <a:t>4/14/2026</a:t>
+              <a:t>4/19/2026</a:t>
             </a:fld>
             <a:endParaRPr lang="en-US"/>
           </a:p>
@@ -4330,7 +4054,7 @@
           <a:p>
             <a:fld id="{0560A9CD-0304-4E0B-9E82-E7E0115DE05B}" type="datetimeFigureOut">
               <a:rPr lang="en-US" smtClean="0"/>
-              <a:t>4/14/2026</a:t>
+              <a:t>4/19/2026</a:t>
             </a:fld>
             <a:endParaRPr lang="en-US"/>
           </a:p>
@@ -4513,7 +4237,7 @@
           <a:p>
             <a:fld id="{0560A9CD-0304-4E0B-9E82-E7E0115DE05B}" type="datetimeFigureOut">
               <a:rPr lang="en-US" smtClean="0"/>
-              <a:t>4/14/2026</a:t>
+              <a:t>4/19/2026</a:t>
             </a:fld>
             <a:endParaRPr lang="en-US"/>
           </a:p>
@@ -4758,7 +4482,7 @@
           <a:p>
             <a:fld id="{0560A9CD-0304-4E0B-9E82-E7E0115DE05B}" type="datetimeFigureOut">
               <a:rPr lang="en-US" smtClean="0"/>
-              <a:t>4/14/2026</a:t>
+              <a:t>4/19/2026</a:t>
             </a:fld>
             <a:endParaRPr lang="en-US"/>
           </a:p>
@@ -4987,7 +4711,7 @@
           <a:p>
             <a:fld id="{0560A9CD-0304-4E0B-9E82-E7E0115DE05B}" type="datetimeFigureOut">
               <a:rPr lang="en-US" smtClean="0"/>
-              <a:t>4/14/2026</a:t>
+              <a:t>4/19/2026</a:t>
             </a:fld>
             <a:endParaRPr lang="en-US"/>
           </a:p>
@@ -5351,7 +5075,7 @@
           <a:p>
             <a:fld id="{0560A9CD-0304-4E0B-9E82-E7E0115DE05B}" type="datetimeFigureOut">
               <a:rPr lang="en-US" smtClean="0"/>
-              <a:t>4/14/2026</a:t>
+              <a:t>4/19/2026</a:t>
             </a:fld>
             <a:endParaRPr lang="en-US"/>
           </a:p>
@@ -5468,7 +5192,7 @@
           <a:p>
             <a:fld id="{0560A9CD-0304-4E0B-9E82-E7E0115DE05B}" type="datetimeFigureOut">
               <a:rPr lang="en-US" smtClean="0"/>
-              <a:t>4/14/2026</a:t>
+              <a:t>4/19/2026</a:t>
             </a:fld>
             <a:endParaRPr lang="en-US"/>
           </a:p>
@@ -5563,7 +5287,7 @@
           <a:p>
             <a:fld id="{0560A9CD-0304-4E0B-9E82-E7E0115DE05B}" type="datetimeFigureOut">
               <a:rPr lang="en-US" smtClean="0"/>
-              <a:t>4/14/2026</a:t>
+              <a:t>4/19/2026</a:t>
             </a:fld>
             <a:endParaRPr lang="en-US"/>
           </a:p>
@@ -5838,7 +5562,7 @@
           <a:p>
             <a:fld id="{0560A9CD-0304-4E0B-9E82-E7E0115DE05B}" type="datetimeFigureOut">
               <a:rPr lang="en-US" smtClean="0"/>
-              <a:t>4/14/2026</a:t>
+              <a:t>4/19/2026</a:t>
             </a:fld>
             <a:endParaRPr lang="en-US"/>
           </a:p>
@@ -6090,7 +5814,7 @@
           <a:p>
             <a:fld id="{0560A9CD-0304-4E0B-9E82-E7E0115DE05B}" type="datetimeFigureOut">
               <a:rPr lang="en-US" smtClean="0"/>
-              <a:t>4/14/2026</a:t>
+              <a:t>4/19/2026</a:t>
             </a:fld>
             <a:endParaRPr lang="en-US"/>
           </a:p>
@@ -6301,7 +6025,7 @@
           <a:p>
             <a:fld id="{0560A9CD-0304-4E0B-9E82-E7E0115DE05B}" type="datetimeFigureOut">
               <a:rPr lang="en-US" smtClean="0"/>
-              <a:t>4/14/2026</a:t>
+              <a:t>4/19/2026</a:t>
             </a:fld>
             <a:endParaRPr lang="en-US"/>
           </a:p>

</xml_diff>